<commit_message>
Course stage 9: INDEX.csv, build script, README; checker passes
Co-Authored-By: Claude Opus 5.5 <noreply@anthropic.com>
Claude-Session: https://claude.ai/code/session_01GeXCBq4kNd1P8DSKw4B2vx
</commit_message>
<xml_diff>
--- a/course/slides/AF-TRACKF-M00/AF-TRACKF-M00-PPP-v1.pptx
+++ b/course/slides/AF-TRACKF-M00/AF-TRACKF-M00-PPP-v1.pptx
@@ -6003,7 +6003,7 @@
                 </a:solidFill>
                 <a:latin typeface="Lexend"/>
               </a:rPr>
-              <a:t>Let us put it together.</a:t>
+              <a:t>Ava now has a plan before she builds anything.</a:t>
             </a:r>
           </a:p>
         </p:txBody>
@@ -8385,7 +8385,7 @@
         </p:blipFill>
         <p:spPr>
           <a:xfrm>
-            <a:off x="609600" y="3185160"/>
+            <a:off x="609600" y="3020060"/>
             <a:ext cx="1016000" cy="1016000"/>
           </a:xfrm>
           <a:prstGeom prst="rect">
@@ -8401,7 +8401,7 @@
         </p:nvSpPr>
         <p:spPr>
           <a:xfrm>
-            <a:off x="2070100" y="3147060"/>
+            <a:off x="2070100" y="2981960"/>
             <a:ext cx="9563100" cy="619760"/>
           </a:xfrm>
           <a:prstGeom prst="rect">
@@ -8440,8 +8440,8 @@
         </p:nvSpPr>
         <p:spPr>
           <a:xfrm>
-            <a:off x="2070100" y="3931920"/>
-            <a:ext cx="9563100" cy="355600"/>
+            <a:off x="2070100" y="3766820"/>
+            <a:ext cx="9563100" cy="685800"/>
           </a:xfrm>
           <a:prstGeom prst="rect">
             <a:avLst/>
@@ -8466,7 +8466,23 @@
                 </a:solidFill>
                 <a:latin typeface="Lexend"/>
               </a:rPr>
-              <a:t>Sam is fifteen.</a:t>
+              <a:t>One weekend he had an idea for a small app to help his gran keep track of</a:t>
+            </a:r>
+          </a:p>
+          <a:p>
+            <a:pPr algn="l">
+              <a:lnSpc>
+                <a:spcPts val="2600"/>
+              </a:lnSpc>
+            </a:pPr>
+            <a:r>
+              <a:rPr sz="2000" b="0">
+                <a:solidFill>
+                  <a:srgbClr val="756E65"/>
+                </a:solidFill>
+                <a:latin typeface="Lexend"/>
+              </a:rPr>
+              <a:t>her dog's walks and feeding times, and he wanted it finished...</a:t>
             </a:r>
           </a:p>
         </p:txBody>
@@ -9739,7 +9755,7 @@
         </p:blipFill>
         <p:spPr>
           <a:xfrm>
-            <a:off x="609600" y="3185160"/>
+            <a:off x="609600" y="3020060"/>
             <a:ext cx="1016000" cy="1016000"/>
           </a:xfrm>
           <a:prstGeom prst="rect">
@@ -9755,7 +9771,7 @@
         </p:nvSpPr>
         <p:spPr>
           <a:xfrm>
-            <a:off x="2070100" y="3147060"/>
+            <a:off x="2070100" y="2981960"/>
             <a:ext cx="9563100" cy="619760"/>
           </a:xfrm>
           <a:prstGeom prst="rect">
@@ -9794,8 +9810,8 @@
         </p:nvSpPr>
         <p:spPr>
           <a:xfrm>
-            <a:off x="2070100" y="3931920"/>
-            <a:ext cx="9563100" cy="355600"/>
+            <a:off x="2070100" y="3766820"/>
+            <a:ext cx="9563100" cy="685800"/>
           </a:xfrm>
           <a:prstGeom prst="rect">
             <a:avLst/>
@@ -9820,7 +9836,23 @@
                 </a:solidFill>
                 <a:latin typeface="Lexend"/>
               </a:rPr>
-              <a:t>The road runs through rooms.</a:t>
+              <a:t>A room is simply where an app sits while it is at a certain stage, so anyone</a:t>
+            </a:r>
+          </a:p>
+          <a:p>
+            <a:pPr algn="l">
+              <a:lnSpc>
+                <a:spcPts val="2600"/>
+              </a:lnSpc>
+            </a:pPr>
+            <a:r>
+              <a:rPr sz="2000" b="0">
+                <a:solidFill>
+                  <a:srgbClr val="756E65"/>
+                </a:solidFill>
+                <a:latin typeface="Lexend"/>
+              </a:rPr>
+              <a:t>can see at a glance what is happening.</a:t>
             </a:r>
           </a:p>
         </p:txBody>
@@ -10631,7 +10663,7 @@
         </p:blipFill>
         <p:spPr>
           <a:xfrm>
-            <a:off x="609600" y="3185160"/>
+            <a:off x="609600" y="3020060"/>
             <a:ext cx="1016000" cy="1016000"/>
           </a:xfrm>
           <a:prstGeom prst="rect">
@@ -10647,7 +10679,7 @@
         </p:nvSpPr>
         <p:spPr>
           <a:xfrm>
-            <a:off x="2070100" y="3147060"/>
+            <a:off x="2070100" y="2981960"/>
             <a:ext cx="9563100" cy="619760"/>
           </a:xfrm>
           <a:prstGeom prst="rect">
@@ -10686,8 +10718,8 @@
         </p:nvSpPr>
         <p:spPr>
           <a:xfrm>
-            <a:off x="2070100" y="3931920"/>
-            <a:ext cx="9563100" cy="355600"/>
+            <a:off x="2070100" y="3766820"/>
+            <a:ext cx="9563100" cy="685800"/>
           </a:xfrm>
           <a:prstGeom prst="rect">
             <a:avLst/>
@@ -10712,7 +10744,23 @@
                 </a:solidFill>
                 <a:latin typeface="Lexend"/>
               </a:rPr>
-              <a:t>Between the stages sit gates.</a:t>
+              <a:t>A gate is a stop point where the app must prove its stage is finished before it</a:t>
+            </a:r>
+          </a:p>
+          <a:p>
+            <a:pPr algn="l">
+              <a:lnSpc>
+                <a:spcPts val="2600"/>
+              </a:lnSpc>
+            </a:pPr>
+            <a:r>
+              <a:rPr sz="2000" b="0">
+                <a:solidFill>
+                  <a:srgbClr val="756E65"/>
+                </a:solidFill>
+                <a:latin typeface="Lexend"/>
+              </a:rPr>
+              <a:t>may move on.</a:t>
             </a:r>
           </a:p>
         </p:txBody>
@@ -12043,7 +12091,7 @@
                 </a:solidFill>
                 <a:latin typeface="Lexend"/>
               </a:rPr>
-              <a:t>Launch is not the end.</a:t>
+              <a:t>A live app goes round a lap, and three lap gates watch it.</a:t>
             </a:r>
           </a:p>
         </p:txBody>
@@ -14448,7 +14496,7 @@
         </p:blipFill>
         <p:spPr>
           <a:xfrm>
-            <a:off x="609600" y="3185160"/>
+            <a:off x="609600" y="3020060"/>
             <a:ext cx="1016000" cy="1016000"/>
           </a:xfrm>
           <a:prstGeom prst="rect">
@@ -14464,7 +14512,7 @@
         </p:nvSpPr>
         <p:spPr>
           <a:xfrm>
-            <a:off x="2070100" y="3147060"/>
+            <a:off x="2070100" y="2981960"/>
             <a:ext cx="9563100" cy="619760"/>
           </a:xfrm>
           <a:prstGeom prst="rect">
@@ -14503,8 +14551,8 @@
         </p:nvSpPr>
         <p:spPr>
           <a:xfrm>
-            <a:off x="2070100" y="3931920"/>
-            <a:ext cx="9563100" cy="355600"/>
+            <a:off x="2070100" y="3766820"/>
+            <a:ext cx="9563100" cy="685800"/>
           </a:xfrm>
           <a:prstGeom prst="rect">
             <a:avLst/>
@@ -14529,7 +14577,23 @@
                 </a:solidFill>
                 <a:latin typeface="Lexend"/>
               </a:rPr>
-              <a:t>Start with screens.</a:t>
+              <a:t>A screen is one page of an app that a person looks at and touches, such as a</a:t>
+            </a:r>
+          </a:p>
+          <a:p>
+            <a:pPr algn="l">
+              <a:lnSpc>
+                <a:spcPts val="2600"/>
+              </a:lnSpc>
+            </a:pPr>
+            <a:r>
+              <a:rPr sz="2000" b="0">
+                <a:solidFill>
+                  <a:srgbClr val="756E65"/>
+                </a:solidFill>
+                <a:latin typeface="Lexend"/>
+              </a:rPr>
+              <a:t>calendar, a form or a list.</a:t>
             </a:r>
           </a:p>
         </p:txBody>
@@ -14894,7 +14958,7 @@
         </p:blipFill>
         <p:spPr>
           <a:xfrm>
-            <a:off x="609600" y="3185160"/>
+            <a:off x="609600" y="3020060"/>
             <a:ext cx="1016000" cy="1016000"/>
           </a:xfrm>
           <a:prstGeom prst="rect">
@@ -14910,7 +14974,7 @@
         </p:nvSpPr>
         <p:spPr>
           <a:xfrm>
-            <a:off x="2070100" y="3147060"/>
+            <a:off x="2070100" y="2981960"/>
             <a:ext cx="9563100" cy="619760"/>
           </a:xfrm>
           <a:prstGeom prst="rect">
@@ -14949,8 +15013,8 @@
         </p:nvSpPr>
         <p:spPr>
           <a:xfrm>
-            <a:off x="2070100" y="3931920"/>
-            <a:ext cx="9563100" cy="355600"/>
+            <a:off x="2070100" y="3766820"/>
+            <a:ext cx="9563100" cy="685800"/>
           </a:xfrm>
           <a:prstGeom prst="rect">
             <a:avLst/>
@@ -14975,7 +15039,23 @@
                 </a:solidFill>
                 <a:latin typeface="Lexend"/>
               </a:rPr>
-              <a:t>Behind the screens sit tables.</a:t>
+              <a:t>A table is where an app stores its data, laid out in rows and columns, rather</a:t>
+            </a:r>
+          </a:p>
+          <a:p>
+            <a:pPr algn="l">
+              <a:lnSpc>
+                <a:spcPts val="2600"/>
+              </a:lnSpc>
+            </a:pPr>
+            <a:r>
+              <a:rPr sz="2000" b="0">
+                <a:solidFill>
+                  <a:srgbClr val="756E65"/>
+                </a:solidFill>
+                <a:latin typeface="Lexend"/>
+              </a:rPr>
+              <a:t>like a spreadsheet.</a:t>
             </a:r>
           </a:p>
         </p:txBody>
@@ -15421,7 +15501,7 @@
                 </a:solidFill>
                 <a:latin typeface="Lexend"/>
               </a:rPr>
-              <a:t>Next come rules.</a:t>
+              <a:t>A rule decides who may see something and who may change it.</a:t>
             </a:r>
           </a:p>
         </p:txBody>
@@ -15786,7 +15866,7 @@
         </p:blipFill>
         <p:spPr>
           <a:xfrm>
-            <a:off x="609600" y="3185160"/>
+            <a:off x="609600" y="3020060"/>
             <a:ext cx="1016000" cy="1016000"/>
           </a:xfrm>
           <a:prstGeom prst="rect">
@@ -15802,7 +15882,7 @@
         </p:nvSpPr>
         <p:spPr>
           <a:xfrm>
-            <a:off x="2070100" y="3147060"/>
+            <a:off x="2070100" y="2981960"/>
             <a:ext cx="9563100" cy="619760"/>
           </a:xfrm>
           <a:prstGeom prst="rect">
@@ -15841,8 +15921,8 @@
         </p:nvSpPr>
         <p:spPr>
           <a:xfrm>
-            <a:off x="2070100" y="3931920"/>
-            <a:ext cx="9563100" cy="355600"/>
+            <a:off x="2070100" y="3766820"/>
+            <a:ext cx="9563100" cy="685800"/>
           </a:xfrm>
           <a:prstGeom prst="rect">
             <a:avLst/>
@@ -15867,7 +15947,23 @@
                 </a:solidFill>
                 <a:latin typeface="Lexend"/>
               </a:rPr>
-              <a:t>The fourth thing is people.</a:t>
+              <a:t>Every app has different kinds of people using it, and each kind needs</a:t>
+            </a:r>
+          </a:p>
+          <a:p>
+            <a:pPr algn="l">
+              <a:lnSpc>
+                <a:spcPts val="2600"/>
+              </a:lnSpc>
+            </a:pPr>
+            <a:r>
+              <a:rPr sz="2000" b="0">
+                <a:solidFill>
+                  <a:srgbClr val="756E65"/>
+                </a:solidFill>
+                <a:latin typeface="Lexend"/>
+              </a:rPr>
+              <a:t>different screens and different rules.</a:t>
             </a:r>
           </a:p>
         </p:txBody>
@@ -16232,7 +16328,7 @@
         </p:blipFill>
         <p:spPr>
           <a:xfrm>
-            <a:off x="609600" y="3185160"/>
+            <a:off x="609600" y="3020060"/>
             <a:ext cx="1016000" cy="1016000"/>
           </a:xfrm>
           <a:prstGeom prst="rect">
@@ -16248,7 +16344,7 @@
         </p:nvSpPr>
         <p:spPr>
           <a:xfrm>
-            <a:off x="2070100" y="3147060"/>
+            <a:off x="2070100" y="2981960"/>
             <a:ext cx="9563100" cy="619760"/>
           </a:xfrm>
           <a:prstGeom prst="rect">
@@ -16287,8 +16383,8 @@
         </p:nvSpPr>
         <p:spPr>
           <a:xfrm>
-            <a:off x="2070100" y="3931920"/>
-            <a:ext cx="9563100" cy="355600"/>
+            <a:off x="2070100" y="3766820"/>
+            <a:ext cx="9563100" cy="685800"/>
           </a:xfrm>
           <a:prstGeom prst="rect">
             <a:avLst/>
@@ -16313,7 +16409,23 @@
                 </a:solidFill>
                 <a:latin typeface="Lexend"/>
               </a:rPr>
-              <a:t>So why does this matter?</a:t>
+              <a:t>Someone starts from a blank page, invents the screens, the tables and the</a:t>
+            </a:r>
+          </a:p>
+          <a:p>
+            <a:pPr algn="l">
+              <a:lnSpc>
+                <a:spcPts val="2600"/>
+              </a:lnSpc>
+            </a:pPr>
+            <a:r>
+              <a:rPr sz="2000" b="0">
+                <a:solidFill>
+                  <a:srgbClr val="756E65"/>
+                </a:solidFill>
+                <a:latin typeface="Lexend"/>
+              </a:rPr>
+              <a:t>rules from nothing, and makes hundreds of choices along the way.</a:t>
             </a:r>
           </a:p>
         </p:txBody>
@@ -16678,7 +16790,7 @@
         </p:blipFill>
         <p:spPr>
           <a:xfrm>
-            <a:off x="609600" y="3185160"/>
+            <a:off x="609600" y="3020060"/>
             <a:ext cx="1016000" cy="1016000"/>
           </a:xfrm>
           <a:prstGeom prst="rect">
@@ -16694,7 +16806,7 @@
         </p:nvSpPr>
         <p:spPr>
           <a:xfrm>
-            <a:off x="2070100" y="3147060"/>
+            <a:off x="2070100" y="2981960"/>
             <a:ext cx="9563100" cy="619760"/>
           </a:xfrm>
           <a:prstGeom prst="rect">
@@ -16733,8 +16845,8 @@
         </p:nvSpPr>
         <p:spPr>
           <a:xfrm>
-            <a:off x="2070100" y="3931920"/>
-            <a:ext cx="9563100" cy="355600"/>
+            <a:off x="2070100" y="3766820"/>
+            <a:ext cx="9563100" cy="685800"/>
           </a:xfrm>
           <a:prstGeom prst="rect">
             <a:avLst/>
@@ -16759,7 +16871,23 @@
                 </a:solidFill>
                 <a:latin typeface="Lexend"/>
               </a:rPr>
-              <a:t>An app factory takes a different route.</a:t>
+              <a:t>Every idea travels the same road, in the same order, with the same checklist</a:t>
+            </a:r>
+          </a:p>
+          <a:p>
+            <a:pPr algn="l">
+              <a:lnSpc>
+                <a:spcPts val="2600"/>
+              </a:lnSpc>
+            </a:pPr>
+            <a:r>
+              <a:rPr sz="2000" b="0">
+                <a:solidFill>
+                  <a:srgbClr val="756E65"/>
+                </a:solidFill>
+                <a:latin typeface="Lexend"/>
+              </a:rPr>
+              <a:t>at each step.</a:t>
             </a:r>
           </a:p>
         </p:txBody>

</xml_diff>